<commit_message>
Update ER diagram assets and reservation fields
Add class and classroom fields to the reservation relationship in schemes/code/er.plantuml. Replace/remove diagram formats: add PNG exports (schemes/imgs/er.png, schemes/imgs/use_case.png), update schemes/imgs/schema_logico.png, and remove outdated SVGs (schemes/svgs/schema_er.svg, schemes/svgs/use_case.svg). Also update docs/AvoLaptops API.pptx. These changes refresh diagram assets and keep the PlantUML model consistent with the exported images.
</commit_message>
<xml_diff>
--- a/docs/AvoLaptops API.pptx
+++ b/docs/AvoLaptops API.pptx
@@ -111,6 +111,11 @@
       </a:defRPr>
     </a:lvl9pPr>
   </p:defaultTextStyle>
+  <p:extLst>
+    <p:ext uri="{EFAFB233-063F-42B5-8137-9DF3F51BA10A}">
+      <p15:sldGuideLst xmlns:p15="http://schemas.microsoft.com/office/powerpoint/2012/main"/>
+    </p:ext>
+  </p:extLst>
 </p:presentation>
 </file>
 
@@ -261,7 +266,7 @@
           <a:p>
             <a:fld id="{9F327778-4F2C-4469-9670-6978CDBE47EC}" type="datetimeFigureOut">
               <a:rPr lang="it-IT" smtClean="0"/>
-              <a:t>17/05/2026</a:t>
+              <a:t>11/06/2026</a:t>
             </a:fld>
             <a:endParaRPr lang="it-IT"/>
           </a:p>
@@ -459,7 +464,7 @@
           <a:p>
             <a:fld id="{9F327778-4F2C-4469-9670-6978CDBE47EC}" type="datetimeFigureOut">
               <a:rPr lang="it-IT" smtClean="0"/>
-              <a:t>17/05/2026</a:t>
+              <a:t>11/06/2026</a:t>
             </a:fld>
             <a:endParaRPr lang="it-IT"/>
           </a:p>
@@ -667,7 +672,7 @@
           <a:p>
             <a:fld id="{9F327778-4F2C-4469-9670-6978CDBE47EC}" type="datetimeFigureOut">
               <a:rPr lang="it-IT" smtClean="0"/>
-              <a:t>17/05/2026</a:t>
+              <a:t>11/06/2026</a:t>
             </a:fld>
             <a:endParaRPr lang="it-IT"/>
           </a:p>
@@ -865,7 +870,7 @@
           <a:p>
             <a:fld id="{9F327778-4F2C-4469-9670-6978CDBE47EC}" type="datetimeFigureOut">
               <a:rPr lang="it-IT" smtClean="0"/>
-              <a:t>17/05/2026</a:t>
+              <a:t>11/06/2026</a:t>
             </a:fld>
             <a:endParaRPr lang="it-IT"/>
           </a:p>
@@ -1140,7 +1145,7 @@
           <a:p>
             <a:fld id="{9F327778-4F2C-4469-9670-6978CDBE47EC}" type="datetimeFigureOut">
               <a:rPr lang="it-IT" smtClean="0"/>
-              <a:t>17/05/2026</a:t>
+              <a:t>11/06/2026</a:t>
             </a:fld>
             <a:endParaRPr lang="it-IT"/>
           </a:p>
@@ -1405,7 +1410,7 @@
           <a:p>
             <a:fld id="{9F327778-4F2C-4469-9670-6978CDBE47EC}" type="datetimeFigureOut">
               <a:rPr lang="it-IT" smtClean="0"/>
-              <a:t>17/05/2026</a:t>
+              <a:t>11/06/2026</a:t>
             </a:fld>
             <a:endParaRPr lang="it-IT"/>
           </a:p>
@@ -1817,7 +1822,7 @@
           <a:p>
             <a:fld id="{9F327778-4F2C-4469-9670-6978CDBE47EC}" type="datetimeFigureOut">
               <a:rPr lang="it-IT" smtClean="0"/>
-              <a:t>17/05/2026</a:t>
+              <a:t>11/06/2026</a:t>
             </a:fld>
             <a:endParaRPr lang="it-IT"/>
           </a:p>
@@ -1958,7 +1963,7 @@
           <a:p>
             <a:fld id="{9F327778-4F2C-4469-9670-6978CDBE47EC}" type="datetimeFigureOut">
               <a:rPr lang="it-IT" smtClean="0"/>
-              <a:t>17/05/2026</a:t>
+              <a:t>11/06/2026</a:t>
             </a:fld>
             <a:endParaRPr lang="it-IT"/>
           </a:p>
@@ -2071,7 +2076,7 @@
           <a:p>
             <a:fld id="{9F327778-4F2C-4469-9670-6978CDBE47EC}" type="datetimeFigureOut">
               <a:rPr lang="it-IT" smtClean="0"/>
-              <a:t>17/05/2026</a:t>
+              <a:t>11/06/2026</a:t>
             </a:fld>
             <a:endParaRPr lang="it-IT"/>
           </a:p>
@@ -2382,7 +2387,7 @@
           <a:p>
             <a:fld id="{9F327778-4F2C-4469-9670-6978CDBE47EC}" type="datetimeFigureOut">
               <a:rPr lang="it-IT" smtClean="0"/>
-              <a:t>17/05/2026</a:t>
+              <a:t>11/06/2026</a:t>
             </a:fld>
             <a:endParaRPr lang="it-IT"/>
           </a:p>
@@ -2670,7 +2675,7 @@
           <a:p>
             <a:fld id="{9F327778-4F2C-4469-9670-6978CDBE47EC}" type="datetimeFigureOut">
               <a:rPr lang="it-IT" smtClean="0"/>
-              <a:t>17/05/2026</a:t>
+              <a:t>11/06/2026</a:t>
             </a:fld>
             <a:endParaRPr lang="it-IT"/>
           </a:p>
@@ -2911,7 +2916,7 @@
           <a:p>
             <a:fld id="{9F327778-4F2C-4469-9670-6978CDBE47EC}" type="datetimeFigureOut">
               <a:rPr lang="it-IT" smtClean="0"/>
-              <a:t>17/05/2026</a:t>
+              <a:t>11/06/2026</a:t>
             </a:fld>
             <a:endParaRPr lang="it-IT"/>
           </a:p>
@@ -3820,10 +3825,10 @@
       </p:sp>
       <p:pic>
         <p:nvPicPr>
-          <p:cNvPr id="5" name="Segnaposto contenuto 4">
-            <a:extLst>
-              <a:ext uri="{FF2B5EF4-FFF2-40B4-BE49-F238E27FC236}">
-                <a16:creationId xmlns:a16="http://schemas.microsoft.com/office/drawing/2014/main" id="{353ECEC5-867C-E92D-E03C-7A0E200917B9}"/>
+          <p:cNvPr id="11" name="Segnaposto contenuto 10">
+            <a:extLst>
+              <a:ext uri="{FF2B5EF4-FFF2-40B4-BE49-F238E27FC236}">
+                <a16:creationId xmlns:a16="http://schemas.microsoft.com/office/drawing/2014/main" id="{28E06358-200E-352D-90E4-2E959FA02AF8}"/>
               </a:ext>
             </a:extLst>
           </p:cNvPr>
@@ -3835,15 +3840,21 @@
           </p:nvPr>
         </p:nvPicPr>
         <p:blipFill>
-          <a:blip r:embed="rId2"/>
+          <a:blip r:embed="rId2">
+            <a:extLst>
+              <a:ext uri="{28A0092B-C50C-407E-A947-70E740481C1C}">
+                <a14:useLocalDpi xmlns:a14="http://schemas.microsoft.com/office/drawing/2010/main" val="0"/>
+              </a:ext>
+            </a:extLst>
+          </a:blip>
           <a:stretch>
             <a:fillRect/>
           </a:stretch>
         </p:blipFill>
         <p:spPr>
           <a:xfrm>
-            <a:off x="1004536" y="1690688"/>
-            <a:ext cx="5039428" cy="4324954"/>
+            <a:off x="2251404" y="1296318"/>
+            <a:ext cx="6933540" cy="5196557"/>
           </a:xfrm>
           <a:prstGeom prst="rect">
             <a:avLst/>
@@ -3911,10 +3922,10 @@
       </p:sp>
       <p:pic>
         <p:nvPicPr>
-          <p:cNvPr id="5" name="Segnaposto contenuto 4">
-            <a:extLst>
-              <a:ext uri="{FF2B5EF4-FFF2-40B4-BE49-F238E27FC236}">
-                <a16:creationId xmlns:a16="http://schemas.microsoft.com/office/drawing/2014/main" id="{0E7D00D4-C217-10B5-09CB-16FC033D7C36}"/>
+          <p:cNvPr id="7" name="Segnaposto contenuto 6">
+            <a:extLst>
+              <a:ext uri="{FF2B5EF4-FFF2-40B4-BE49-F238E27FC236}">
+                <a16:creationId xmlns:a16="http://schemas.microsoft.com/office/drawing/2014/main" id="{1D9BA8A0-B3F8-4842-5274-08B51CA3E87E}"/>
               </a:ext>
             </a:extLst>
           </p:cNvPr>
@@ -3926,15 +3937,21 @@
           </p:nvPr>
         </p:nvPicPr>
         <p:blipFill>
-          <a:blip r:embed="rId2"/>
+          <a:blip r:embed="rId2">
+            <a:extLst>
+              <a:ext uri="{28A0092B-C50C-407E-A947-70E740481C1C}">
+                <a14:useLocalDpi xmlns:a14="http://schemas.microsoft.com/office/drawing/2010/main" val="0"/>
+              </a:ext>
+            </a:extLst>
+          </a:blip>
           <a:stretch>
             <a:fillRect/>
           </a:stretch>
         </p:blipFill>
         <p:spPr>
           <a:xfrm>
-            <a:off x="3269268" y="1606550"/>
-            <a:ext cx="5855682" cy="5479388"/>
+            <a:off x="1303287" y="1825625"/>
+            <a:ext cx="9585426" cy="4351338"/>
           </a:xfrm>
           <a:prstGeom prst="rect">
             <a:avLst/>
@@ -4001,10 +4018,10 @@
       </p:sp>
       <p:pic>
         <p:nvPicPr>
-          <p:cNvPr id="7" name="Elemento grafico 2">
-            <a:extLst>
-              <a:ext uri="{FF2B5EF4-FFF2-40B4-BE49-F238E27FC236}">
-                <a16:creationId xmlns:a16="http://schemas.microsoft.com/office/drawing/2014/main" id="{DB2B5515-1A61-C149-0C14-4CC8FC2483FF}"/>
+          <p:cNvPr id="6" name="Segnaposto contenuto 5">
+            <a:extLst>
+              <a:ext uri="{FF2B5EF4-FFF2-40B4-BE49-F238E27FC236}">
+                <a16:creationId xmlns:a16="http://schemas.microsoft.com/office/drawing/2014/main" id="{90F4F905-2C7E-F13D-3D44-E029EEB8F195}"/>
               </a:ext>
             </a:extLst>
           </p:cNvPr>
@@ -4016,21 +4033,22 @@
           </p:nvPr>
         </p:nvPicPr>
         <p:blipFill>
-          <a:blip>
-            <a:extLst>
-              <a:ext uri="{96DAC541-7B7A-43D3-8B79-37D633B846F1}">
-                <asvg:svgBlip xmlns:asvg="http://schemas.microsoft.com/office/drawing/2016/SVG/main" r:embed="rId2"/>
+          <a:blip r:embed="rId2">
+            <a:extLst>
+              <a:ext uri="{28A0092B-C50C-407E-A947-70E740481C1C}">
+                <a14:useLocalDpi xmlns:a14="http://schemas.microsoft.com/office/drawing/2010/main" val="0"/>
               </a:ext>
             </a:extLst>
           </a:blip>
+          <a:srcRect t="1593" r="1371" b="54693"/>
           <a:stretch>
             <a:fillRect/>
           </a:stretch>
         </p:blipFill>
         <p:spPr>
           <a:xfrm>
-            <a:off x="908051" y="1438275"/>
-            <a:ext cx="5512238" cy="11441464"/>
+            <a:off x="911686" y="1562669"/>
+            <a:ext cx="5192165" cy="4804012"/>
           </a:xfrm>
           <a:prstGeom prst="rect">
             <a:avLst/>
@@ -4039,10 +4057,10 @@
       </p:pic>
       <p:pic>
         <p:nvPicPr>
-          <p:cNvPr id="8" name="Elemento grafico 2">
-            <a:extLst>
-              <a:ext uri="{FF2B5EF4-FFF2-40B4-BE49-F238E27FC236}">
-                <a16:creationId xmlns:a16="http://schemas.microsoft.com/office/drawing/2014/main" id="{0A31F59A-AF8A-73A2-414B-67E54B3B00FC}"/>
+          <p:cNvPr id="10" name="Immagine 9">
+            <a:extLst>
+              <a:ext uri="{FF2B5EF4-FFF2-40B4-BE49-F238E27FC236}">
+                <a16:creationId xmlns:a16="http://schemas.microsoft.com/office/drawing/2014/main" id="{5957A661-82F9-76F8-E921-26AC4A4FEB1A}"/>
               </a:ext>
             </a:extLst>
           </p:cNvPr>
@@ -4052,21 +4070,22 @@
           <p:nvPr/>
         </p:nvPicPr>
         <p:blipFill>
-          <a:blip>
-            <a:extLst>
-              <a:ext uri="{96DAC541-7B7A-43D3-8B79-37D633B846F1}">
-                <asvg:svgBlip xmlns:asvg="http://schemas.microsoft.com/office/drawing/2016/SVG/main" r:embed="rId2"/>
+          <a:blip r:embed="rId2">
+            <a:extLst>
+              <a:ext uri="{28A0092B-C50C-407E-A947-70E740481C1C}">
+                <a14:useLocalDpi xmlns:a14="http://schemas.microsoft.com/office/drawing/2010/main" val="0"/>
               </a:ext>
             </a:extLst>
           </a:blip>
+          <a:srcRect t="37413"/>
           <a:stretch>
             <a:fillRect/>
           </a:stretch>
         </p:blipFill>
         <p:spPr>
           <a:xfrm>
-            <a:off x="5771711" y="-4692826"/>
-            <a:ext cx="5512238" cy="11441464"/>
+            <a:off x="6425498" y="1214651"/>
+            <a:ext cx="4152210" cy="5424984"/>
           </a:xfrm>
           <a:prstGeom prst="rect">
             <a:avLst/>

</xml_diff>

<commit_message>
Update AvoLaptops API presentation
Replace the docs/AvoLaptops API.pptx file with an updated binary presentation. No code changes; only the documentation slide deck was updated.
</commit_message>
<xml_diff>
--- a/docs/AvoLaptops API.pptx
+++ b/docs/AvoLaptops API.pptx
@@ -7,12 +7,13 @@
   <p:sldIdLst>
     <p:sldId id="256" r:id="rId2"/>
     <p:sldId id="257" r:id="rId3"/>
-    <p:sldId id="260" r:id="rId4"/>
-    <p:sldId id="258" r:id="rId5"/>
-    <p:sldId id="259" r:id="rId6"/>
-    <p:sldId id="261" r:id="rId7"/>
-    <p:sldId id="262" r:id="rId8"/>
-    <p:sldId id="263" r:id="rId9"/>
+    <p:sldId id="264" r:id="rId4"/>
+    <p:sldId id="260" r:id="rId5"/>
+    <p:sldId id="258" r:id="rId6"/>
+    <p:sldId id="259" r:id="rId7"/>
+    <p:sldId id="261" r:id="rId8"/>
+    <p:sldId id="262" r:id="rId9"/>
+    <p:sldId id="263" r:id="rId10"/>
   </p:sldIdLst>
   <p:sldSz cx="12192000" cy="6858000"/>
   <p:notesSz cx="6858000" cy="9144000"/>
@@ -266,7 +267,7 @@
           <a:p>
             <a:fld id="{9F327778-4F2C-4469-9670-6978CDBE47EC}" type="datetimeFigureOut">
               <a:rPr lang="it-IT" smtClean="0"/>
-              <a:t>11/06/2026</a:t>
+              <a:t>12/06/2026</a:t>
             </a:fld>
             <a:endParaRPr lang="it-IT"/>
           </a:p>
@@ -464,7 +465,7 @@
           <a:p>
             <a:fld id="{9F327778-4F2C-4469-9670-6978CDBE47EC}" type="datetimeFigureOut">
               <a:rPr lang="it-IT" smtClean="0"/>
-              <a:t>11/06/2026</a:t>
+              <a:t>12/06/2026</a:t>
             </a:fld>
             <a:endParaRPr lang="it-IT"/>
           </a:p>
@@ -672,7 +673,7 @@
           <a:p>
             <a:fld id="{9F327778-4F2C-4469-9670-6978CDBE47EC}" type="datetimeFigureOut">
               <a:rPr lang="it-IT" smtClean="0"/>
-              <a:t>11/06/2026</a:t>
+              <a:t>12/06/2026</a:t>
             </a:fld>
             <a:endParaRPr lang="it-IT"/>
           </a:p>
@@ -870,7 +871,7 @@
           <a:p>
             <a:fld id="{9F327778-4F2C-4469-9670-6978CDBE47EC}" type="datetimeFigureOut">
               <a:rPr lang="it-IT" smtClean="0"/>
-              <a:t>11/06/2026</a:t>
+              <a:t>12/06/2026</a:t>
             </a:fld>
             <a:endParaRPr lang="it-IT"/>
           </a:p>
@@ -1145,7 +1146,7 @@
           <a:p>
             <a:fld id="{9F327778-4F2C-4469-9670-6978CDBE47EC}" type="datetimeFigureOut">
               <a:rPr lang="it-IT" smtClean="0"/>
-              <a:t>11/06/2026</a:t>
+              <a:t>12/06/2026</a:t>
             </a:fld>
             <a:endParaRPr lang="it-IT"/>
           </a:p>
@@ -1410,7 +1411,7 @@
           <a:p>
             <a:fld id="{9F327778-4F2C-4469-9670-6978CDBE47EC}" type="datetimeFigureOut">
               <a:rPr lang="it-IT" smtClean="0"/>
-              <a:t>11/06/2026</a:t>
+              <a:t>12/06/2026</a:t>
             </a:fld>
             <a:endParaRPr lang="it-IT"/>
           </a:p>
@@ -1822,7 +1823,7 @@
           <a:p>
             <a:fld id="{9F327778-4F2C-4469-9670-6978CDBE47EC}" type="datetimeFigureOut">
               <a:rPr lang="it-IT" smtClean="0"/>
-              <a:t>11/06/2026</a:t>
+              <a:t>12/06/2026</a:t>
             </a:fld>
             <a:endParaRPr lang="it-IT"/>
           </a:p>
@@ -1963,7 +1964,7 @@
           <a:p>
             <a:fld id="{9F327778-4F2C-4469-9670-6978CDBE47EC}" type="datetimeFigureOut">
               <a:rPr lang="it-IT" smtClean="0"/>
-              <a:t>11/06/2026</a:t>
+              <a:t>12/06/2026</a:t>
             </a:fld>
             <a:endParaRPr lang="it-IT"/>
           </a:p>
@@ -2076,7 +2077,7 @@
           <a:p>
             <a:fld id="{9F327778-4F2C-4469-9670-6978CDBE47EC}" type="datetimeFigureOut">
               <a:rPr lang="it-IT" smtClean="0"/>
-              <a:t>11/06/2026</a:t>
+              <a:t>12/06/2026</a:t>
             </a:fld>
             <a:endParaRPr lang="it-IT"/>
           </a:p>
@@ -2387,7 +2388,7 @@
           <a:p>
             <a:fld id="{9F327778-4F2C-4469-9670-6978CDBE47EC}" type="datetimeFigureOut">
               <a:rPr lang="it-IT" smtClean="0"/>
-              <a:t>11/06/2026</a:t>
+              <a:t>12/06/2026</a:t>
             </a:fld>
             <a:endParaRPr lang="it-IT"/>
           </a:p>
@@ -2675,7 +2676,7 @@
           <a:p>
             <a:fld id="{9F327778-4F2C-4469-9670-6978CDBE47EC}" type="datetimeFigureOut">
               <a:rPr lang="it-IT" smtClean="0"/>
-              <a:t>11/06/2026</a:t>
+              <a:t>12/06/2026</a:t>
             </a:fld>
             <a:endParaRPr lang="it-IT"/>
           </a:p>
@@ -2916,7 +2917,7 @@
           <a:p>
             <a:fld id="{9F327778-4F2C-4469-9670-6978CDBE47EC}" type="datetimeFigureOut">
               <a:rPr lang="it-IT" smtClean="0"/>
-              <a:t>11/06/2026</a:t>
+              <a:t>12/06/2026</a:t>
             </a:fld>
             <a:endParaRPr lang="it-IT"/>
           </a:p>
@@ -3518,10 +3519,15 @@
             <p:ph idx="1"/>
           </p:nvPr>
         </p:nvSpPr>
-        <p:spPr/>
+        <p:spPr>
+          <a:xfrm>
+            <a:off x="838200" y="1825625"/>
+            <a:ext cx="4514850" cy="4351338"/>
+          </a:xfrm>
+        </p:spPr>
         <p:txBody>
           <a:bodyPr>
-            <a:normAutofit fontScale="85000" lnSpcReduction="20000"/>
+            <a:normAutofit lnSpcReduction="10000"/>
           </a:bodyPr>
           <a:lstStyle/>
           <a:p>
@@ -3597,7 +3603,15 @@
             </a:r>
             <a:r>
               <a:rPr lang="it-IT" dirty="0"/>
-              <a:t> su tutti i dispositivi con l’uso dell’API REST. Utilizza PHP come </a:t>
+              <a:t> su tutti i dispositivi con l’uso dell’</a:t>
+            </a:r>
+            <a:r>
+              <a:rPr lang="it-IT" b="1" dirty="0"/>
+              <a:t>API REST</a:t>
+            </a:r>
+            <a:r>
+              <a:rPr lang="it-IT" dirty="0"/>
+              <a:t>. Utilizza PHP come </a:t>
             </a:r>
             <a:r>
               <a:rPr lang="it-IT" dirty="0" err="1"/>
@@ -3608,163 +3622,44 @@
               <a:t>.</a:t>
             </a:r>
           </a:p>
-          <a:p>
-            <a:r>
-              <a:rPr lang="it-IT" dirty="0"/>
-              <a:t>Il </a:t>
-            </a:r>
-            <a:r>
-              <a:rPr lang="it-IT" b="1" dirty="0"/>
-              <a:t>database</a:t>
-            </a:r>
-            <a:r>
-              <a:rPr lang="it-IT" dirty="0"/>
-              <a:t> è creato con il </a:t>
-            </a:r>
-            <a:r>
-              <a:rPr lang="it-IT" b="1" dirty="0"/>
-              <a:t>DBMS</a:t>
-            </a:r>
-            <a:r>
-              <a:rPr lang="it-IT" dirty="0"/>
-              <a:t>: </a:t>
-            </a:r>
-            <a:r>
-              <a:rPr lang="it-IT" b="1" dirty="0"/>
-              <a:t>MySQL</a:t>
-            </a:r>
-            <a:r>
-              <a:rPr lang="it-IT" dirty="0"/>
-              <a:t> e presenta </a:t>
-            </a:r>
-            <a:r>
-              <a:rPr lang="it-IT" b="1" dirty="0"/>
-              <a:t>4</a:t>
-            </a:r>
-            <a:r>
-              <a:rPr lang="it-IT" dirty="0"/>
-              <a:t> </a:t>
-            </a:r>
-            <a:r>
-              <a:rPr lang="it-IT" b="1" dirty="0"/>
-              <a:t>tabelle</a:t>
-            </a:r>
-            <a:r>
-              <a:rPr lang="it-IT" dirty="0"/>
-              <a:t> principali: </a:t>
-            </a:r>
-            <a:r>
-              <a:rPr lang="it-IT" dirty="0" err="1"/>
-              <a:t>reservations</a:t>
-            </a:r>
-            <a:r>
-              <a:rPr lang="it-IT" dirty="0"/>
-              <a:t>, laptops, users e </a:t>
-            </a:r>
-            <a:r>
-              <a:rPr lang="it-IT" dirty="0" err="1"/>
-              <a:t>lockers</a:t>
-            </a:r>
-            <a:r>
-              <a:rPr lang="it-IT" dirty="0"/>
-              <a:t>.</a:t>
-            </a:r>
-          </a:p>
-          <a:p>
-            <a:r>
-              <a:rPr lang="it-IT" dirty="0"/>
-              <a:t>Gli utenti sono divisi in: </a:t>
-            </a:r>
-            <a:r>
-              <a:rPr lang="it-IT" b="1" dirty="0"/>
-              <a:t>admins</a:t>
-            </a:r>
-            <a:r>
-              <a:rPr lang="it-IT" dirty="0"/>
-              <a:t> (docenti oppure gestori del progetto) e </a:t>
-            </a:r>
-            <a:r>
-              <a:rPr lang="it-IT" b="1" dirty="0" err="1"/>
-              <a:t>teachers</a:t>
-            </a:r>
-            <a:r>
-              <a:rPr lang="it-IT" dirty="0"/>
-              <a:t>. </a:t>
-            </a:r>
-          </a:p>
-          <a:p>
-            <a:r>
-              <a:rPr lang="it-IT" dirty="0"/>
-              <a:t>La prenotazione è possibile solo tramite </a:t>
-            </a:r>
-            <a:r>
-              <a:rPr lang="it-IT" b="1" dirty="0"/>
-              <a:t>Account Istituzionali </a:t>
-            </a:r>
-            <a:r>
-              <a:rPr lang="it-IT" dirty="0"/>
-              <a:t>di docenti con il dominio </a:t>
-            </a:r>
-            <a:r>
-              <a:rPr lang="it-IT" b="1" dirty="0"/>
-              <a:t>itisavogadro.it</a:t>
-            </a:r>
-            <a:r>
-              <a:rPr lang="it-IT" dirty="0"/>
-              <a:t>. Gli amministratori possono accedere solo se il loro account è stato approvato da un altro amministratore.</a:t>
-            </a:r>
-          </a:p>
-          <a:p>
-            <a:r>
-              <a:rPr lang="it-IT" dirty="0"/>
-              <a:t>Il docente deve selezionare </a:t>
-            </a:r>
-            <a:r>
-              <a:rPr lang="it-IT" b="1" dirty="0"/>
-              <a:t>una fascia oraria</a:t>
-            </a:r>
-            <a:r>
-              <a:rPr lang="it-IT" dirty="0"/>
-              <a:t> per cui prenota una serie di </a:t>
-            </a:r>
-            <a:r>
-              <a:rPr lang="it-IT" b="1" dirty="0"/>
-              <a:t>PC</a:t>
-            </a:r>
-            <a:r>
-              <a:rPr lang="it-IT" dirty="0"/>
-              <a:t> che sono presentati con le </a:t>
-            </a:r>
-            <a:r>
-              <a:rPr lang="it-IT" b="1" dirty="0"/>
-              <a:t>caratteristiche tecniche generali</a:t>
-            </a:r>
-            <a:r>
-              <a:rPr lang="it-IT" dirty="0"/>
-              <a:t>.  Ogni </a:t>
-            </a:r>
-            <a:r>
-              <a:rPr lang="it-IT" b="1" dirty="0"/>
-              <a:t>portatile</a:t>
-            </a:r>
-            <a:r>
-              <a:rPr lang="it-IT" dirty="0"/>
-              <a:t> è </a:t>
-            </a:r>
-            <a:r>
-              <a:rPr lang="it-IT" b="1" dirty="0"/>
-              <a:t>custodito</a:t>
-            </a:r>
-            <a:r>
-              <a:rPr lang="it-IT" dirty="0"/>
-              <a:t> in un luogo che per generalizzazione è definito Locker.</a:t>
-            </a:r>
-          </a:p>
-          <a:p>
-            <a:endParaRPr lang="it-IT" dirty="0"/>
-          </a:p>
-        </p:txBody>
-      </p:sp>
+        </p:txBody>
+      </p:sp>
+      <p:pic>
+        <p:nvPicPr>
+          <p:cNvPr id="7" name="Elemento grafico 6">
+            <a:extLst>
+              <a:ext uri="{FF2B5EF4-FFF2-40B4-BE49-F238E27FC236}">
+                <a16:creationId xmlns:a16="http://schemas.microsoft.com/office/drawing/2014/main" id="{F315BF22-1F7B-6112-2B8D-7DEBB1DA0F17}"/>
+              </a:ext>
+            </a:extLst>
+          </p:cNvPr>
+          <p:cNvPicPr>
+            <a:picLocks noChangeAspect="1"/>
+          </p:cNvPicPr>
+          <p:nvPr/>
+        </p:nvPicPr>
+        <p:blipFill>
+          <a:blip>
+            <a:extLst>
+              <a:ext uri="{96DAC541-7B7A-43D3-8B79-37D633B846F1}">
+                <asvg:svgBlip xmlns:asvg="http://schemas.microsoft.com/office/drawing/2016/SVG/main" r:embed="rId2"/>
+              </a:ext>
+            </a:extLst>
+          </a:blip>
+          <a:stretch>
+            <a:fillRect/>
+          </a:stretch>
+        </p:blipFill>
+        <p:spPr>
+          <a:xfrm>
+            <a:off x="6610350" y="1825625"/>
+            <a:ext cx="3797300" cy="3797300"/>
+          </a:xfrm>
+          <a:prstGeom prst="rect">
+            <a:avLst/>
+          </a:prstGeom>
+        </p:spPr>
+      </p:pic>
     </p:spTree>
     <p:extLst>
       <p:ext uri="{BB962C8B-B14F-4D97-AF65-F5344CB8AC3E}">
@@ -3779,6 +3674,191 @@
 </file>
 
 <file path=ppt/slides/slide3.xml><?xml version="1.0" encoding="utf-8"?>
+<p:sld xmlns:a="http://schemas.openxmlformats.org/drawingml/2006/main" xmlns:r="http://schemas.openxmlformats.org/officeDocument/2006/relationships" xmlns:p="http://schemas.openxmlformats.org/presentationml/2006/main">
+  <p:cSld>
+    <p:spTree>
+      <p:nvGrpSpPr>
+        <p:cNvPr id="1" name="">
+          <a:extLst>
+            <a:ext uri="{FF2B5EF4-FFF2-40B4-BE49-F238E27FC236}">
+              <a16:creationId xmlns:a16="http://schemas.microsoft.com/office/drawing/2014/main" id="{1FBD2DF2-C75C-FCDD-31B2-1F8D97E771A9}"/>
+            </a:ext>
+          </a:extLst>
+        </p:cNvPr>
+        <p:cNvGrpSpPr/>
+        <p:nvPr/>
+      </p:nvGrpSpPr>
+      <p:grpSpPr>
+        <a:xfrm>
+          <a:off x="0" y="0"/>
+          <a:ext cx="0" cy="0"/>
+          <a:chOff x="0" y="0"/>
+          <a:chExt cx="0" cy="0"/>
+        </a:xfrm>
+      </p:grpSpPr>
+      <p:sp>
+        <p:nvSpPr>
+          <p:cNvPr id="2" name="Titolo 1">
+            <a:extLst>
+              <a:ext uri="{FF2B5EF4-FFF2-40B4-BE49-F238E27FC236}">
+                <a16:creationId xmlns:a16="http://schemas.microsoft.com/office/drawing/2014/main" id="{8C8E5498-720F-FE3F-5CCE-2784D9CC18BB}"/>
+              </a:ext>
+            </a:extLst>
+          </p:cNvPr>
+          <p:cNvSpPr>
+            <a:spLocks noGrp="1"/>
+          </p:cNvSpPr>
+          <p:nvPr>
+            <p:ph type="title"/>
+          </p:nvPr>
+        </p:nvSpPr>
+        <p:spPr/>
+        <p:txBody>
+          <a:bodyPr/>
+          <a:lstStyle/>
+          <a:p>
+            <a:r>
+              <a:rPr lang="it-IT" b="1" dirty="0">
+                <a:solidFill>
+                  <a:srgbClr val="FF0000"/>
+                </a:solidFill>
+              </a:rPr>
+              <a:t>Abstract</a:t>
+            </a:r>
+          </a:p>
+        </p:txBody>
+      </p:sp>
+      <p:sp>
+        <p:nvSpPr>
+          <p:cNvPr id="3" name="Segnaposto contenuto 2">
+            <a:extLst>
+              <a:ext uri="{FF2B5EF4-FFF2-40B4-BE49-F238E27FC236}">
+                <a16:creationId xmlns:a16="http://schemas.microsoft.com/office/drawing/2014/main" id="{A62B2B11-E41F-B095-0805-753B320F2D42}"/>
+              </a:ext>
+            </a:extLst>
+          </p:cNvPr>
+          <p:cNvSpPr>
+            <a:spLocks noGrp="1"/>
+          </p:cNvSpPr>
+          <p:nvPr>
+            <p:ph idx="1"/>
+          </p:nvPr>
+        </p:nvSpPr>
+        <p:spPr/>
+        <p:txBody>
+          <a:bodyPr>
+            <a:normAutofit/>
+          </a:bodyPr>
+          <a:lstStyle/>
+          <a:p>
+            <a:r>
+              <a:rPr lang="it-IT" dirty="0"/>
+              <a:t>Gli utenti sono divisi in: </a:t>
+            </a:r>
+            <a:r>
+              <a:rPr lang="it-IT" b="1" dirty="0"/>
+              <a:t>admins</a:t>
+            </a:r>
+            <a:r>
+              <a:rPr lang="it-IT" dirty="0"/>
+              <a:t> (docenti oppure gestori del progetto) e </a:t>
+            </a:r>
+            <a:r>
+              <a:rPr lang="it-IT" b="1" dirty="0" err="1"/>
+              <a:t>teachers</a:t>
+            </a:r>
+            <a:r>
+              <a:rPr lang="it-IT" dirty="0"/>
+              <a:t>. </a:t>
+            </a:r>
+          </a:p>
+          <a:p>
+            <a:r>
+              <a:rPr lang="it-IT" dirty="0"/>
+              <a:t>La prenotazione è possibile solo tramite </a:t>
+            </a:r>
+            <a:r>
+              <a:rPr lang="it-IT" b="1" dirty="0"/>
+              <a:t>Account Istituzionali </a:t>
+            </a:r>
+            <a:r>
+              <a:rPr lang="it-IT" dirty="0"/>
+              <a:t>di docenti con il dominio </a:t>
+            </a:r>
+            <a:r>
+              <a:rPr lang="it-IT" b="1" dirty="0"/>
+              <a:t>itisavogadro.it</a:t>
+            </a:r>
+            <a:r>
+              <a:rPr lang="it-IT" dirty="0"/>
+              <a:t>. Gli amministratori possono accedere solo se il loro account è stato approvato da un altro amministratore.</a:t>
+            </a:r>
+          </a:p>
+          <a:p>
+            <a:r>
+              <a:rPr lang="it-IT" dirty="0"/>
+              <a:t>Il docente deve selezionare </a:t>
+            </a:r>
+            <a:r>
+              <a:rPr lang="it-IT" b="1" dirty="0"/>
+              <a:t>una fascia oraria</a:t>
+            </a:r>
+            <a:r>
+              <a:rPr lang="it-IT" dirty="0"/>
+              <a:t> per cui prenota una serie di </a:t>
+            </a:r>
+            <a:r>
+              <a:rPr lang="it-IT" b="1" dirty="0"/>
+              <a:t>PC</a:t>
+            </a:r>
+            <a:r>
+              <a:rPr lang="it-IT" dirty="0"/>
+              <a:t> che sono presentati con le </a:t>
+            </a:r>
+            <a:r>
+              <a:rPr lang="it-IT" b="1" dirty="0"/>
+              <a:t>caratteristiche tecniche generali</a:t>
+            </a:r>
+            <a:r>
+              <a:rPr lang="it-IT" dirty="0"/>
+              <a:t>.  Ogni </a:t>
+            </a:r>
+            <a:r>
+              <a:rPr lang="it-IT" b="1" dirty="0"/>
+              <a:t>portatile</a:t>
+            </a:r>
+            <a:r>
+              <a:rPr lang="it-IT" dirty="0"/>
+              <a:t> è </a:t>
+            </a:r>
+            <a:r>
+              <a:rPr lang="it-IT" b="1" dirty="0"/>
+              <a:t>custodito</a:t>
+            </a:r>
+            <a:r>
+              <a:rPr lang="it-IT" dirty="0"/>
+              <a:t> in un luogo che per generalizzazione è definito Locker.</a:t>
+            </a:r>
+          </a:p>
+          <a:p>
+            <a:endParaRPr lang="it-IT" dirty="0"/>
+          </a:p>
+        </p:txBody>
+      </p:sp>
+    </p:spTree>
+    <p:extLst>
+      <p:ext uri="{BB962C8B-B14F-4D97-AF65-F5344CB8AC3E}">
+        <p14:creationId xmlns:p14="http://schemas.microsoft.com/office/powerpoint/2010/main" val="3553188154"/>
+      </p:ext>
+    </p:extLst>
+  </p:cSld>
+  <p:clrMapOvr>
+    <a:masterClrMapping/>
+  </p:clrMapOvr>
+</p:sld>
+</file>
+
+<file path=ppt/slides/slide4.xml><?xml version="1.0" encoding="utf-8"?>
 <p:sld xmlns:a="http://schemas.openxmlformats.org/drawingml/2006/main" xmlns:r="http://schemas.openxmlformats.org/officeDocument/2006/relationships" xmlns:p="http://schemas.openxmlformats.org/presentationml/2006/main">
   <p:cSld>
     <p:spTree>
@@ -3874,7 +3954,7 @@
 </p:sld>
 </file>
 
-<file path=ppt/slides/slide4.xml><?xml version="1.0" encoding="utf-8"?>
+<file path=ppt/slides/slide5.xml><?xml version="1.0" encoding="utf-8"?>
 <p:sld xmlns:a="http://schemas.openxmlformats.org/drawingml/2006/main" xmlns:r="http://schemas.openxmlformats.org/officeDocument/2006/relationships" xmlns:p="http://schemas.openxmlformats.org/presentationml/2006/main">
   <p:cSld>
     <p:spTree>
@@ -3971,7 +4051,7 @@
 </p:sld>
 </file>
 
-<file path=ppt/slides/slide5.xml><?xml version="1.0" encoding="utf-8"?>
+<file path=ppt/slides/slide6.xml><?xml version="1.0" encoding="utf-8"?>
 <p:sld xmlns:a="http://schemas.openxmlformats.org/drawingml/2006/main" xmlns:r="http://schemas.openxmlformats.org/officeDocument/2006/relationships" xmlns:p="http://schemas.openxmlformats.org/presentationml/2006/main">
   <p:cSld>
     <p:spTree>
@@ -4105,7 +4185,7 @@
 </p:sld>
 </file>
 
-<file path=ppt/slides/slide6.xml><?xml version="1.0" encoding="utf-8"?>
+<file path=ppt/slides/slide7.xml><?xml version="1.0" encoding="utf-8"?>
 <p:sld xmlns:a="http://schemas.openxmlformats.org/drawingml/2006/main" xmlns:r="http://schemas.openxmlformats.org/officeDocument/2006/relationships" xmlns:p="http://schemas.openxmlformats.org/presentationml/2006/main">
   <p:cSld>
     <p:spTree>
@@ -4195,7 +4275,7 @@
 </p:sld>
 </file>
 
-<file path=ppt/slides/slide7.xml><?xml version="1.0" encoding="utf-8"?>
+<file path=ppt/slides/slide8.xml><?xml version="1.0" encoding="utf-8"?>
 <p:sld xmlns:a="http://schemas.openxmlformats.org/drawingml/2006/main" xmlns:r="http://schemas.openxmlformats.org/officeDocument/2006/relationships" xmlns:p="http://schemas.openxmlformats.org/presentationml/2006/main">
   <p:cSld>
     <p:spTree>
@@ -4258,6 +4338,7 @@
         </p:nvPicPr>
         <p:blipFill>
           <a:blip r:embed="rId2"/>
+          <a:srcRect r="39146"/>
           <a:stretch>
             <a:fillRect/>
           </a:stretch>
@@ -4265,7 +4346,7 @@
         <p:spPr>
           <a:xfrm>
             <a:off x="939800" y="1387474"/>
-            <a:ext cx="8921750" cy="5353869"/>
+            <a:ext cx="5429250" cy="5353869"/>
           </a:xfrm>
           <a:prstGeom prst="rect">
             <a:avLst/>
@@ -4285,7 +4366,7 @@
 </p:sld>
 </file>
 
-<file path=ppt/slides/slide8.xml><?xml version="1.0" encoding="utf-8"?>
+<file path=ppt/slides/slide9.xml><?xml version="1.0" encoding="utf-8"?>
 <p:sld xmlns:a="http://schemas.openxmlformats.org/drawingml/2006/main" xmlns:r="http://schemas.openxmlformats.org/officeDocument/2006/relationships" xmlns:p="http://schemas.openxmlformats.org/presentationml/2006/main">
   <p:cSld>
     <p:spTree>
@@ -4332,19 +4413,17 @@
       </p:sp>
       <p:pic>
         <p:nvPicPr>
-          <p:cNvPr id="5" name="Segnaposto contenuto 4">
-            <a:extLst>
-              <a:ext uri="{FF2B5EF4-FFF2-40B4-BE49-F238E27FC236}">
-                <a16:creationId xmlns:a16="http://schemas.microsoft.com/office/drawing/2014/main" id="{020CD4D6-8579-AD38-2179-EBD51018537A}"/>
+          <p:cNvPr id="8" name="Immagine 7">
+            <a:extLst>
+              <a:ext uri="{FF2B5EF4-FFF2-40B4-BE49-F238E27FC236}">
+                <a16:creationId xmlns:a16="http://schemas.microsoft.com/office/drawing/2014/main" id="{6C4F96B9-3FFD-4DFE-D1B9-8CA32C2C2E32}"/>
               </a:ext>
             </a:extLst>
           </p:cNvPr>
           <p:cNvPicPr>
-            <a:picLocks noGrp="1" noChangeAspect="1"/>
+            <a:picLocks noChangeAspect="1"/>
           </p:cNvPicPr>
-          <p:nvPr>
-            <p:ph idx="1"/>
-          </p:nvPr>
+          <p:nvPr/>
         </p:nvPicPr>
         <p:blipFill>
           <a:blip r:embed="rId2"/>
@@ -4354,8 +4433,8 @@
         </p:blipFill>
         <p:spPr>
           <a:xfrm>
-            <a:off x="933450" y="1362074"/>
-            <a:ext cx="9201150" cy="5370485"/>
+            <a:off x="948922" y="1386133"/>
+            <a:ext cx="8376224" cy="4398717"/>
           </a:xfrm>
           <a:prstGeom prst="rect">
             <a:avLst/>
@@ -4364,10 +4443,10 @@
       </p:pic>
       <p:sp>
         <p:nvSpPr>
-          <p:cNvPr id="7" name="CasellaDiTesto 6">
-            <a:extLst>
-              <a:ext uri="{FF2B5EF4-FFF2-40B4-BE49-F238E27FC236}">
-                <a16:creationId xmlns:a16="http://schemas.microsoft.com/office/drawing/2014/main" id="{16BE7337-4876-B42C-362E-7545ADFB93B4}"/>
+          <p:cNvPr id="12" name="CasellaDiTesto 11">
+            <a:extLst>
+              <a:ext uri="{FF2B5EF4-FFF2-40B4-BE49-F238E27FC236}">
+                <a16:creationId xmlns:a16="http://schemas.microsoft.com/office/drawing/2014/main" id="{3A032D76-AEB7-9F53-8EB4-E8E78C8F0F3D}"/>
               </a:ext>
             </a:extLst>
           </p:cNvPr>
@@ -4376,8 +4455,8 @@
         </p:nvSpPr>
         <p:spPr>
           <a:xfrm>
-            <a:off x="3759200" y="4127500"/>
-            <a:ext cx="6375400" cy="2031325"/>
+            <a:off x="9355310" y="1101864"/>
+            <a:ext cx="2836690" cy="5632311"/>
           </a:xfrm>
           <a:prstGeom prst="rect">
             <a:avLst/>
@@ -4390,596 +4469,424 @@
           </a:bodyPr>
           <a:lstStyle/>
           <a:p>
-            <a:pPr>
-              <a:buNone/>
-            </a:pPr>
-            <a:r>
-              <a:rPr lang="it-IT" b="0" dirty="0">
-                <a:solidFill>
-                  <a:srgbClr val="9CDCFE"/>
-                </a:solidFill>
-                <a:effectLst/>
-                <a:latin typeface="IBMPlexMono,  Courier New"/>
+            <a:r>
+              <a:rPr lang="it-IT" dirty="0">
+                <a:solidFill>
+                  <a:srgbClr val="426BB3"/>
+                </a:solidFill>
               </a:rPr>
-              <a:t>"query"</a:t>
-            </a:r>
-            <a:r>
-              <a:rPr lang="it-IT" b="0" dirty="0">
-                <a:solidFill>
-                  <a:srgbClr val="DCDCDC"/>
-                </a:solidFill>
-                <a:effectLst/>
-                <a:latin typeface="IBMPlexMono,  Courier New"/>
+              <a:t>"query": </a:t>
+            </a:r>
+            <a:r>
+              <a:rPr lang="it-IT" dirty="0">
+                <a:solidFill>
+                  <a:srgbClr val="C97B30"/>
+                </a:solidFill>
               </a:rPr>
-              <a:t>:</a:t>
-            </a:r>
-            <a:r>
-              <a:rPr lang="it-IT" b="0" dirty="0">
-                <a:solidFill>
-                  <a:srgbClr val="D4D4D4"/>
-                </a:solidFill>
-                <a:effectLst/>
-                <a:latin typeface="IBMPlexMono,  Courier New"/>
-              </a:rPr>
-              <a:t> </a:t>
-            </a:r>
-            <a:r>
-              <a:rPr lang="it-IT" b="0" dirty="0">
-                <a:solidFill>
-                  <a:srgbClr val="CE9178"/>
-                </a:solidFill>
-                <a:effectLst/>
-                <a:latin typeface="IBMPlexMono,  Courier New"/>
-              </a:rPr>
-              <a:t>"SELECT </a:t>
-            </a:r>
-            <a:r>
-              <a:rPr lang="it-IT" b="0" dirty="0" err="1">
-                <a:solidFill>
-                  <a:srgbClr val="CE9178"/>
-                </a:solidFill>
-                <a:effectLst/>
-                <a:latin typeface="IBMPlexMono,  Courier New"/>
+              <a:t>"SELECT </a:t>
+            </a:r>
+            <a:r>
+              <a:rPr lang="it-IT" dirty="0" err="1">
+                <a:solidFill>
+                  <a:srgbClr val="C97B30"/>
+                </a:solidFill>
               </a:rPr>
               <a:t>r.id_reservation</a:t>
             </a:r>
             <a:r>
-              <a:rPr lang="it-IT" b="0" dirty="0">
-                <a:solidFill>
-                  <a:srgbClr val="CE9178"/>
-                </a:solidFill>
-                <a:effectLst/>
-                <a:latin typeface="IBMPlexMono,  Courier New"/>
+              <a:rPr lang="it-IT" dirty="0">
+                <a:solidFill>
+                  <a:srgbClr val="C97B30"/>
+                </a:solidFill>
               </a:rPr>
-              <a:t>, </a:t>
-            </a:r>
-            <a:r>
-              <a:rPr lang="it-IT" b="0" dirty="0" err="1">
-                <a:solidFill>
-                  <a:srgbClr val="CE9178"/>
-                </a:solidFill>
-                <a:effectLst/>
-                <a:latin typeface="IBMPlexMono,  Courier New"/>
+              <a:t>, </a:t>
+            </a:r>
+            <a:r>
+              <a:rPr lang="it-IT" dirty="0" err="1">
+                <a:solidFill>
+                  <a:srgbClr val="C97B30"/>
+                </a:solidFill>
               </a:rPr>
               <a:t>r.date</a:t>
             </a:r>
             <a:r>
-              <a:rPr lang="it-IT" b="0" dirty="0">
-                <a:solidFill>
-                  <a:srgbClr val="CE9178"/>
-                </a:solidFill>
-                <a:effectLst/>
-                <a:latin typeface="IBMPlexMono,  Courier New"/>
+              <a:rPr lang="it-IT" dirty="0">
+                <a:solidFill>
+                  <a:srgbClr val="C97B30"/>
+                </a:solidFill>
               </a:rPr>
-              <a:t>, </a:t>
-            </a:r>
-            <a:r>
-              <a:rPr lang="it-IT" b="0" dirty="0" err="1">
-                <a:solidFill>
-                  <a:srgbClr val="CE9178"/>
-                </a:solidFill>
-                <a:effectLst/>
-                <a:latin typeface="IBMPlexMono,  Courier New"/>
+              <a:t>, </a:t>
+            </a:r>
+            <a:r>
+              <a:rPr lang="it-IT" dirty="0" err="1">
+                <a:solidFill>
+                  <a:srgbClr val="C97B30"/>
+                </a:solidFill>
               </a:rPr>
               <a:t>r.time_start</a:t>
             </a:r>
             <a:r>
-              <a:rPr lang="it-IT" b="0" dirty="0">
-                <a:solidFill>
-                  <a:srgbClr val="CE9178"/>
-                </a:solidFill>
-                <a:effectLst/>
-                <a:latin typeface="IBMPlexMono,  Courier New"/>
+              <a:rPr lang="it-IT" dirty="0">
+                <a:solidFill>
+                  <a:srgbClr val="C97B30"/>
+                </a:solidFill>
               </a:rPr>
-              <a:t>, </a:t>
-            </a:r>
-            <a:r>
-              <a:rPr lang="it-IT" b="0" dirty="0" err="1">
-                <a:solidFill>
-                  <a:srgbClr val="CE9178"/>
-                </a:solidFill>
-                <a:effectLst/>
-                <a:latin typeface="IBMPlexMono,  Courier New"/>
+              <a:t>, </a:t>
+            </a:r>
+            <a:r>
+              <a:rPr lang="it-IT" dirty="0" err="1">
+                <a:solidFill>
+                  <a:srgbClr val="C97B30"/>
+                </a:solidFill>
               </a:rPr>
               <a:t>r.time_end</a:t>
             </a:r>
             <a:r>
-              <a:rPr lang="it-IT" b="0" dirty="0">
-                <a:solidFill>
-                  <a:srgbClr val="CE9178"/>
-                </a:solidFill>
-                <a:effectLst/>
-                <a:latin typeface="IBMPlexMono,  Courier New"/>
+              <a:rPr lang="it-IT" dirty="0">
+                <a:solidFill>
+                  <a:srgbClr val="C97B30"/>
+                </a:solidFill>
               </a:rPr>
-              <a:t>, </a:t>
-            </a:r>
-            <a:r>
-              <a:rPr lang="it-IT" b="0" dirty="0" err="1">
-                <a:solidFill>
-                  <a:srgbClr val="CE9178"/>
-                </a:solidFill>
-                <a:effectLst/>
-                <a:latin typeface="IBMPlexMono,  Courier New"/>
+              <a:t>, </a:t>
+            </a:r>
+            <a:r>
+              <a:rPr lang="it-IT" dirty="0" err="1">
+                <a:solidFill>
+                  <a:srgbClr val="C97B30"/>
+                </a:solidFill>
               </a:rPr>
               <a:t>r.status</a:t>
             </a:r>
             <a:r>
-              <a:rPr lang="it-IT" b="0" dirty="0">
-                <a:solidFill>
-                  <a:srgbClr val="CE9178"/>
-                </a:solidFill>
-                <a:effectLst/>
-                <a:latin typeface="IBMPlexMono,  Courier New"/>
+              <a:rPr lang="it-IT" dirty="0">
+                <a:solidFill>
+                  <a:srgbClr val="C97B30"/>
+                </a:solidFill>
               </a:rPr>
-              <a:t>, </a:t>
-            </a:r>
-            <a:r>
-              <a:rPr lang="it-IT" b="0" dirty="0" err="1">
-                <a:solidFill>
-                  <a:srgbClr val="CE9178"/>
-                </a:solidFill>
-                <a:effectLst/>
-                <a:latin typeface="IBMPlexMono,  Courier New"/>
+              <a:t>, </a:t>
+            </a:r>
+            <a:r>
+              <a:rPr lang="it-IT" dirty="0" err="1">
+                <a:solidFill>
+                  <a:srgbClr val="C97B30"/>
+                </a:solidFill>
+              </a:rPr>
+              <a:t>r.class</a:t>
+            </a:r>
+            <a:r>
+              <a:rPr lang="it-IT" dirty="0">
+                <a:solidFill>
+                  <a:srgbClr val="C97B30"/>
+                </a:solidFill>
+              </a:rPr>
+              <a:t>, </a:t>
+            </a:r>
+            <a:r>
+              <a:rPr lang="it-IT" dirty="0" err="1">
+                <a:solidFill>
+                  <a:srgbClr val="C97B30"/>
+                </a:solidFill>
+              </a:rPr>
+              <a:t>r.classroom</a:t>
+            </a:r>
+            <a:r>
+              <a:rPr lang="it-IT" dirty="0">
+                <a:solidFill>
+                  <a:srgbClr val="C97B30"/>
+                </a:solidFill>
+              </a:rPr>
+              <a:t>, </a:t>
+            </a:r>
+            <a:r>
+              <a:rPr lang="it-IT" dirty="0" err="1">
+                <a:solidFill>
+                  <a:srgbClr val="C97B30"/>
+                </a:solidFill>
               </a:rPr>
               <a:t>u.id_user</a:t>
             </a:r>
             <a:r>
-              <a:rPr lang="it-IT" b="0" dirty="0">
-                <a:solidFill>
-                  <a:srgbClr val="CE9178"/>
-                </a:solidFill>
-                <a:effectLst/>
-                <a:latin typeface="IBMPlexMono,  Courier New"/>
+              <a:rPr lang="it-IT" dirty="0">
+                <a:solidFill>
+                  <a:srgbClr val="C97B30"/>
+                </a:solidFill>
               </a:rPr>
-              <a:t>, u.name, </a:t>
-            </a:r>
-            <a:r>
-              <a:rPr lang="it-IT" b="0" dirty="0" err="1">
-                <a:solidFill>
-                  <a:srgbClr val="CE9178"/>
-                </a:solidFill>
-                <a:effectLst/>
-                <a:latin typeface="IBMPlexMono,  Courier New"/>
+              <a:t>, u.name, </a:t>
+            </a:r>
+            <a:r>
+              <a:rPr lang="it-IT" dirty="0" err="1">
+                <a:solidFill>
+                  <a:srgbClr val="C97B30"/>
+                </a:solidFill>
               </a:rPr>
               <a:t>u.surname</a:t>
             </a:r>
             <a:r>
-              <a:rPr lang="it-IT" b="0" dirty="0">
-                <a:solidFill>
-                  <a:srgbClr val="CE9178"/>
-                </a:solidFill>
-                <a:effectLst/>
-                <a:latin typeface="IBMPlexMono,  Courier New"/>
+              <a:rPr lang="it-IT" dirty="0">
+                <a:solidFill>
+                  <a:srgbClr val="C97B30"/>
+                </a:solidFill>
               </a:rPr>
-              <a:t>, </a:t>
-            </a:r>
-            <a:r>
-              <a:rPr lang="it-IT" b="0" dirty="0" err="1">
-                <a:solidFill>
-                  <a:srgbClr val="CE9178"/>
-                </a:solidFill>
-                <a:effectLst/>
-                <a:latin typeface="IBMPlexMono,  Courier New"/>
+              <a:t>, </a:t>
+            </a:r>
+            <a:r>
+              <a:rPr lang="it-IT" dirty="0" err="1">
+                <a:solidFill>
+                  <a:srgbClr val="C97B30"/>
+                </a:solidFill>
               </a:rPr>
               <a:t>u.email</a:t>
             </a:r>
             <a:r>
-              <a:rPr lang="it-IT" b="0" dirty="0">
-                <a:solidFill>
-                  <a:srgbClr val="CE9178"/>
-                </a:solidFill>
-                <a:effectLst/>
-                <a:latin typeface="IBMPlexMono,  Courier New"/>
+              <a:rPr lang="it-IT" dirty="0">
+                <a:solidFill>
+                  <a:srgbClr val="C97B30"/>
+                </a:solidFill>
               </a:rPr>
-              <a:t>, </a:t>
-            </a:r>
-            <a:r>
-              <a:rPr lang="it-IT" b="0" dirty="0" err="1">
-                <a:solidFill>
-                  <a:srgbClr val="CE9178"/>
-                </a:solidFill>
-                <a:effectLst/>
-                <a:latin typeface="IBMPlexMono,  Courier New"/>
-              </a:rPr>
-              <a:t>u.password</a:t>
-            </a:r>
-            <a:r>
-              <a:rPr lang="it-IT" b="0" dirty="0">
-                <a:solidFill>
-                  <a:srgbClr val="CE9178"/>
-                </a:solidFill>
-                <a:effectLst/>
-                <a:latin typeface="IBMPlexMono,  Courier New"/>
-              </a:rPr>
-              <a:t>, </a:t>
-            </a:r>
-            <a:r>
-              <a:rPr lang="it-IT" b="0" dirty="0" err="1">
-                <a:solidFill>
-                  <a:srgbClr val="CE9178"/>
-                </a:solidFill>
-                <a:effectLst/>
-                <a:latin typeface="IBMPlexMono,  Courier New"/>
+              <a:t>, </a:t>
+            </a:r>
+            <a:r>
+              <a:rPr lang="it-IT" dirty="0" err="1">
+                <a:solidFill>
+                  <a:srgbClr val="C97B30"/>
+                </a:solidFill>
               </a:rPr>
               <a:t>u.role</a:t>
             </a:r>
             <a:r>
-              <a:rPr lang="it-IT" b="0" dirty="0">
-                <a:solidFill>
-                  <a:srgbClr val="CE9178"/>
-                </a:solidFill>
-                <a:effectLst/>
-                <a:latin typeface="IBMPlexMono,  Courier New"/>
+              <a:rPr lang="it-IT" dirty="0">
+                <a:solidFill>
+                  <a:srgbClr val="C97B30"/>
+                </a:solidFill>
               </a:rPr>
-              <a:t>, </a:t>
-            </a:r>
-            <a:r>
-              <a:rPr lang="it-IT" b="0" dirty="0" err="1">
-                <a:solidFill>
-                  <a:srgbClr val="CE9178"/>
-                </a:solidFill>
-                <a:effectLst/>
-                <a:latin typeface="IBMPlexMono,  Courier New"/>
+              <a:t>, </a:t>
+            </a:r>
+            <a:r>
+              <a:rPr lang="it-IT" dirty="0" err="1">
+                <a:solidFill>
+                  <a:srgbClr val="C97B30"/>
+                </a:solidFill>
               </a:rPr>
               <a:t>laptops.id_laptop</a:t>
             </a:r>
             <a:r>
-              <a:rPr lang="it-IT" b="0" dirty="0">
-                <a:solidFill>
-                  <a:srgbClr val="CE9178"/>
-                </a:solidFill>
-                <a:effectLst/>
-                <a:latin typeface="IBMPlexMono,  Courier New"/>
+              <a:rPr lang="it-IT" dirty="0">
+                <a:solidFill>
+                  <a:srgbClr val="C97B30"/>
+                </a:solidFill>
               </a:rPr>
-              <a:t>, </a:t>
-            </a:r>
-            <a:r>
-              <a:rPr lang="it-IT" b="0" dirty="0" err="1">
-                <a:solidFill>
-                  <a:srgbClr val="CE9178"/>
-                </a:solidFill>
-                <a:effectLst/>
-                <a:latin typeface="IBMPlexMono,  Courier New"/>
-              </a:rPr>
-              <a:t>laptops.status</a:t>
-            </a:r>
-            <a:r>
-              <a:rPr lang="it-IT" b="0" dirty="0">
-                <a:solidFill>
-                  <a:srgbClr val="CE9178"/>
-                </a:solidFill>
-                <a:effectLst/>
-                <a:latin typeface="IBMPlexMono,  Courier New"/>
-              </a:rPr>
-              <a:t>, m.*, l.* from </a:t>
-            </a:r>
-            <a:r>
-              <a:rPr lang="it-IT" b="0" dirty="0" err="1">
-                <a:solidFill>
-                  <a:srgbClr val="CE9178"/>
-                </a:solidFill>
-                <a:effectLst/>
-                <a:latin typeface="IBMPlexMono,  Courier New"/>
+              <a:t>, m.*, l.* from </a:t>
+            </a:r>
+            <a:r>
+              <a:rPr lang="it-IT" dirty="0" err="1">
+                <a:solidFill>
+                  <a:srgbClr val="C97B30"/>
+                </a:solidFill>
               </a:rPr>
               <a:t>reservations</a:t>
             </a:r>
             <a:r>
-              <a:rPr lang="it-IT" b="0" dirty="0">
-                <a:solidFill>
-                  <a:srgbClr val="CE9178"/>
-                </a:solidFill>
-                <a:effectLst/>
-                <a:latin typeface="IBMPlexMono,  Courier New"/>
+              <a:rPr lang="it-IT" dirty="0">
+                <a:solidFill>
+                  <a:srgbClr val="C97B30"/>
+                </a:solidFill>
               </a:rPr>
-              <a:t> r\</a:t>
-            </a:r>
-            <a:r>
-              <a:rPr lang="it-IT" b="0" dirty="0" err="1">
-                <a:solidFill>
-                  <a:srgbClr val="CE9178"/>
-                </a:solidFill>
-                <a:effectLst/>
-                <a:latin typeface="IBMPlexMono,  Courier New"/>
+              <a:t> r</a:t>
+            </a:r>
+          </a:p>
+          <a:p>
+            <a:r>
+              <a:rPr lang="it-IT" dirty="0">
+                <a:solidFill>
+                  <a:srgbClr val="C97B30"/>
+                </a:solidFill>
               </a:rPr>
-              <a:t>nINNER</a:t>
-            </a:r>
-            <a:r>
-              <a:rPr lang="it-IT" b="0" dirty="0">
-                <a:solidFill>
-                  <a:srgbClr val="CE9178"/>
-                </a:solidFill>
-                <a:effectLst/>
-                <a:latin typeface="IBMPlexMono,  Courier New"/>
-              </a:rPr>
-              <a:t> JOIN laptops ON </a:t>
-            </a:r>
-            <a:r>
-              <a:rPr lang="it-IT" b="0" dirty="0" err="1">
-                <a:solidFill>
-                  <a:srgbClr val="CE9178"/>
-                </a:solidFill>
-                <a:effectLst/>
-                <a:latin typeface="IBMPlexMono,  Courier New"/>
+              <a:t>INNER JOIN laptops ON </a:t>
+            </a:r>
+            <a:r>
+              <a:rPr lang="it-IT" dirty="0" err="1">
+                <a:solidFill>
+                  <a:srgbClr val="C97B30"/>
+                </a:solidFill>
               </a:rPr>
               <a:t>laptops.id_laptop</a:t>
             </a:r>
             <a:r>
-              <a:rPr lang="it-IT" b="0" dirty="0">
-                <a:solidFill>
-                  <a:srgbClr val="CE9178"/>
-                </a:solidFill>
-                <a:effectLst/>
-                <a:latin typeface="IBMPlexMono,  Courier New"/>
+              <a:rPr lang="it-IT" dirty="0">
+                <a:solidFill>
+                  <a:srgbClr val="C97B30"/>
+                </a:solidFill>
               </a:rPr>
-              <a:t> = </a:t>
-            </a:r>
-            <a:r>
-              <a:rPr lang="it-IT" b="0" dirty="0" err="1">
-                <a:solidFill>
-                  <a:srgbClr val="CE9178"/>
-                </a:solidFill>
-                <a:effectLst/>
-                <a:latin typeface="IBMPlexMono,  Courier New"/>
+              <a:t> = </a:t>
+            </a:r>
+            <a:r>
+              <a:rPr lang="it-IT" dirty="0" err="1">
+                <a:solidFill>
+                  <a:srgbClr val="C97B30"/>
+                </a:solidFill>
               </a:rPr>
               <a:t>r.id_laptop</a:t>
             </a:r>
-            <a:r>
-              <a:rPr lang="it-IT" b="0" dirty="0">
-                <a:solidFill>
-                  <a:srgbClr val="CE9178"/>
-                </a:solidFill>
-                <a:effectLst/>
-                <a:latin typeface="IBMPlexMono,  Courier New"/>
+            <a:endParaRPr lang="it-IT" dirty="0">
+              <a:solidFill>
+                <a:srgbClr val="C97B30"/>
+              </a:solidFill>
+            </a:endParaRPr>
+          </a:p>
+          <a:p>
+            <a:r>
+              <a:rPr lang="it-IT" dirty="0">
+                <a:solidFill>
+                  <a:srgbClr val="C97B30"/>
+                </a:solidFill>
               </a:rPr>
-              <a:t>\</a:t>
-            </a:r>
-            <a:r>
-              <a:rPr lang="it-IT" b="0" dirty="0" err="1">
-                <a:solidFill>
-                  <a:srgbClr val="CE9178"/>
-                </a:solidFill>
-                <a:effectLst/>
-                <a:latin typeface="IBMPlexMono,  Courier New"/>
-              </a:rPr>
-              <a:t>nINNER</a:t>
-            </a:r>
-            <a:r>
-              <a:rPr lang="it-IT" b="0" dirty="0">
-                <a:solidFill>
-                  <a:srgbClr val="CE9178"/>
-                </a:solidFill>
-                <a:effectLst/>
-                <a:latin typeface="IBMPlexMono,  Courier New"/>
-              </a:rPr>
-              <a:t> JOIN models m ON </a:t>
-            </a:r>
-            <a:r>
-              <a:rPr lang="it-IT" b="0" dirty="0" err="1">
-                <a:solidFill>
-                  <a:srgbClr val="CE9178"/>
-                </a:solidFill>
-                <a:effectLst/>
-                <a:latin typeface="IBMPlexMono,  Courier New"/>
+              <a:t>INNER JOIN models m ON </a:t>
+            </a:r>
+            <a:r>
+              <a:rPr lang="it-IT" dirty="0" err="1">
+                <a:solidFill>
+                  <a:srgbClr val="C97B30"/>
+                </a:solidFill>
               </a:rPr>
               <a:t>laptops.id_model</a:t>
             </a:r>
             <a:r>
-              <a:rPr lang="it-IT" b="0" dirty="0">
-                <a:solidFill>
-                  <a:srgbClr val="CE9178"/>
-                </a:solidFill>
-                <a:effectLst/>
-                <a:latin typeface="IBMPlexMono,  Courier New"/>
+              <a:rPr lang="it-IT" dirty="0">
+                <a:solidFill>
+                  <a:srgbClr val="C97B30"/>
+                </a:solidFill>
               </a:rPr>
-              <a:t> = </a:t>
-            </a:r>
-            <a:r>
-              <a:rPr lang="it-IT" b="0" dirty="0" err="1">
-                <a:solidFill>
-                  <a:srgbClr val="CE9178"/>
-                </a:solidFill>
-                <a:effectLst/>
-                <a:latin typeface="IBMPlexMono,  Courier New"/>
+              <a:t> = </a:t>
+            </a:r>
+            <a:r>
+              <a:rPr lang="it-IT" dirty="0" err="1">
+                <a:solidFill>
+                  <a:srgbClr val="C97B30"/>
+                </a:solidFill>
               </a:rPr>
               <a:t>m.id_model</a:t>
             </a:r>
             <a:r>
-              <a:rPr lang="it-IT" b="0" dirty="0">
-                <a:solidFill>
-                  <a:srgbClr val="CE9178"/>
-                </a:solidFill>
-                <a:effectLst/>
-                <a:latin typeface="IBMPlexMono,  Courier New"/>
+              <a:rPr lang="it-IT" dirty="0">
+                <a:solidFill>
+                  <a:srgbClr val="C97B30"/>
+                </a:solidFill>
               </a:rPr>
-              <a:t> \</a:t>
-            </a:r>
-            <a:r>
-              <a:rPr lang="it-IT" b="0" dirty="0" err="1">
-                <a:solidFill>
-                  <a:srgbClr val="CE9178"/>
-                </a:solidFill>
-                <a:effectLst/>
-                <a:latin typeface="IBMPlexMono,  Courier New"/>
+              <a:t> </a:t>
+            </a:r>
+          </a:p>
+          <a:p>
+            <a:r>
+              <a:rPr lang="it-IT" dirty="0">
+                <a:solidFill>
+                  <a:srgbClr val="C97B30"/>
+                </a:solidFill>
               </a:rPr>
-              <a:t>nINNER</a:t>
-            </a:r>
-            <a:r>
-              <a:rPr lang="it-IT" b="0" dirty="0">
-                <a:solidFill>
-                  <a:srgbClr val="CE9178"/>
-                </a:solidFill>
-                <a:effectLst/>
-                <a:latin typeface="IBMPlexMono,  Courier New"/>
-              </a:rPr>
-              <a:t> JOIN </a:t>
-            </a:r>
-            <a:r>
-              <a:rPr lang="it-IT" b="0" dirty="0" err="1">
-                <a:solidFill>
-                  <a:srgbClr val="CE9178"/>
-                </a:solidFill>
-                <a:effectLst/>
-                <a:latin typeface="IBMPlexMono,  Courier New"/>
+              <a:t>INNER JOIN </a:t>
+            </a:r>
+            <a:r>
+              <a:rPr lang="it-IT" dirty="0" err="1">
+                <a:solidFill>
+                  <a:srgbClr val="C97B30"/>
+                </a:solidFill>
               </a:rPr>
               <a:t>lockers</a:t>
             </a:r>
             <a:r>
-              <a:rPr lang="it-IT" b="0" dirty="0">
-                <a:solidFill>
-                  <a:srgbClr val="CE9178"/>
-                </a:solidFill>
-                <a:effectLst/>
-                <a:latin typeface="IBMPlexMono,  Courier New"/>
+              <a:rPr lang="it-IT" dirty="0">
+                <a:solidFill>
+                  <a:srgbClr val="C97B30"/>
+                </a:solidFill>
               </a:rPr>
-              <a:t> l ON </a:t>
-            </a:r>
-            <a:r>
-              <a:rPr lang="it-IT" b="0" dirty="0" err="1">
-                <a:solidFill>
-                  <a:srgbClr val="CE9178"/>
-                </a:solidFill>
-                <a:effectLst/>
-                <a:latin typeface="IBMPlexMono,  Courier New"/>
+              <a:t> l ON </a:t>
+            </a:r>
+            <a:r>
+              <a:rPr lang="it-IT" dirty="0" err="1">
+                <a:solidFill>
+                  <a:srgbClr val="C97B30"/>
+                </a:solidFill>
               </a:rPr>
               <a:t>laptops.id_locker</a:t>
             </a:r>
             <a:r>
-              <a:rPr lang="it-IT" b="0" dirty="0">
-                <a:solidFill>
-                  <a:srgbClr val="CE9178"/>
-                </a:solidFill>
-                <a:effectLst/>
-                <a:latin typeface="IBMPlexMono,  Courier New"/>
+              <a:rPr lang="it-IT" dirty="0">
+                <a:solidFill>
+                  <a:srgbClr val="C97B30"/>
+                </a:solidFill>
               </a:rPr>
-              <a:t> = </a:t>
-            </a:r>
-            <a:r>
-              <a:rPr lang="it-IT" b="0" dirty="0" err="1">
-                <a:solidFill>
-                  <a:srgbClr val="CE9178"/>
-                </a:solidFill>
-                <a:effectLst/>
-                <a:latin typeface="IBMPlexMono,  Courier New"/>
+              <a:t> = </a:t>
+            </a:r>
+            <a:r>
+              <a:rPr lang="it-IT" dirty="0" err="1">
+                <a:solidFill>
+                  <a:srgbClr val="C97B30"/>
+                </a:solidFill>
               </a:rPr>
               <a:t>l.id_locker</a:t>
             </a:r>
-            <a:r>
-              <a:rPr lang="it-IT" b="0" dirty="0">
-                <a:solidFill>
-                  <a:srgbClr val="CE9178"/>
-                </a:solidFill>
-                <a:effectLst/>
-                <a:latin typeface="IBMPlexMono,  Courier New"/>
+            <a:endParaRPr lang="it-IT" dirty="0">
+              <a:solidFill>
+                <a:srgbClr val="C97B30"/>
+              </a:solidFill>
+            </a:endParaRPr>
+          </a:p>
+          <a:p>
+            <a:r>
+              <a:rPr lang="it-IT" dirty="0">
+                <a:solidFill>
+                  <a:srgbClr val="C97B30"/>
+                </a:solidFill>
               </a:rPr>
-              <a:t>\</a:t>
-            </a:r>
-            <a:r>
-              <a:rPr lang="it-IT" b="0" dirty="0" err="1">
-                <a:solidFill>
-                  <a:srgbClr val="CE9178"/>
-                </a:solidFill>
-                <a:effectLst/>
-                <a:latin typeface="IBMPlexMono,  Courier New"/>
-              </a:rPr>
-              <a:t>nINNER</a:t>
-            </a:r>
-            <a:r>
-              <a:rPr lang="it-IT" b="0" dirty="0">
-                <a:solidFill>
-                  <a:srgbClr val="CE9178"/>
-                </a:solidFill>
-                <a:effectLst/>
-                <a:latin typeface="IBMPlexMono,  Courier New"/>
-              </a:rPr>
-              <a:t> JOIN users u ON </a:t>
-            </a:r>
-            <a:r>
-              <a:rPr lang="it-IT" b="0" dirty="0" err="1">
-                <a:solidFill>
-                  <a:srgbClr val="CE9178"/>
-                </a:solidFill>
-                <a:effectLst/>
-                <a:latin typeface="IBMPlexMono,  Courier New"/>
+              <a:t>INNER JOIN users u ON </a:t>
+            </a:r>
+            <a:r>
+              <a:rPr lang="it-IT" dirty="0" err="1">
+                <a:solidFill>
+                  <a:srgbClr val="C97B30"/>
+                </a:solidFill>
               </a:rPr>
               <a:t>u.id_user</a:t>
             </a:r>
             <a:r>
-              <a:rPr lang="it-IT" b="0" dirty="0">
-                <a:solidFill>
-                  <a:srgbClr val="CE9178"/>
-                </a:solidFill>
-                <a:effectLst/>
-                <a:latin typeface="IBMPlexMono,  Courier New"/>
+              <a:rPr lang="it-IT" dirty="0">
+                <a:solidFill>
+                  <a:srgbClr val="C97B30"/>
+                </a:solidFill>
               </a:rPr>
-              <a:t> = </a:t>
-            </a:r>
-            <a:r>
-              <a:rPr lang="it-IT" b="0" dirty="0" err="1">
-                <a:solidFill>
-                  <a:srgbClr val="CE9178"/>
-                </a:solidFill>
-                <a:effectLst/>
-                <a:latin typeface="IBMPlexMono,  Courier New"/>
+              <a:t> = </a:t>
+            </a:r>
+            <a:r>
+              <a:rPr lang="it-IT" dirty="0" err="1">
+                <a:solidFill>
+                  <a:srgbClr val="C97B30"/>
+                </a:solidFill>
               </a:rPr>
               <a:t>r.id_user</a:t>
             </a:r>
             <a:r>
-              <a:rPr lang="it-IT" b="0" dirty="0">
-                <a:solidFill>
-                  <a:srgbClr val="CE9178"/>
-                </a:solidFill>
-                <a:effectLst/>
-                <a:latin typeface="IBMPlexMono,  Courier New"/>
+              <a:rPr lang="it-IT" dirty="0">
+                <a:solidFill>
+                  <a:srgbClr val="C97B30"/>
+                </a:solidFill>
               </a:rPr>
-              <a:t> WHERE </a:t>
-            </a:r>
-            <a:r>
-              <a:rPr lang="it-IT" b="0" dirty="0" err="1">
-                <a:solidFill>
-                  <a:srgbClr val="CE9178"/>
-                </a:solidFill>
-                <a:effectLst/>
-                <a:latin typeface="IBMPlexMono,  Courier New"/>
+              <a:t> WHERE </a:t>
+            </a:r>
+            <a:r>
+              <a:rPr lang="it-IT" dirty="0" err="1">
+                <a:solidFill>
+                  <a:srgbClr val="C97B30"/>
+                </a:solidFill>
               </a:rPr>
               <a:t>id_reservation</a:t>
             </a:r>
             <a:r>
-              <a:rPr lang="it-IT" b="0" dirty="0">
-                <a:solidFill>
-                  <a:srgbClr val="CE9178"/>
-                </a:solidFill>
-                <a:effectLst/>
-                <a:latin typeface="IBMPlexMono,  Courier New"/>
+              <a:rPr lang="it-IT" dirty="0">
+                <a:solidFill>
+                  <a:srgbClr val="C97B30"/>
+                </a:solidFill>
               </a:rPr>
-              <a:t> = ? "</a:t>
-            </a:r>
-            <a:endParaRPr lang="it-IT" b="0" dirty="0">
-              <a:solidFill>
-                <a:srgbClr val="D4D4D4"/>
-              </a:solidFill>
-              <a:effectLst/>
-              <a:latin typeface="IBMPlexMono,  Courier New"/>
-            </a:endParaRPr>
+              <a:t> = ? "</a:t>
+            </a:r>
           </a:p>
         </p:txBody>
       </p:sp>

</xml_diff>